<commit_message>
docs: sync github issue evidence
</commit_message>
<xml_diff>
--- a/Report Test subject/slides/Powered by GPT - Software Quality Verification - Presentation.pptx
+++ b/Report Test subject/slides/Powered by GPT - Software Quality Verification - Presentation.pptx
@@ -139,7 +139,7 @@
           <p:cNvPr id="2" name="Title 1">
             <a:extLst>
               <a:ext uri="{FF2B5EF4-FFF2-40B4-BE49-F238E27FC236}">
-                <a16:creationId xmlns:a16="http://schemas.microsoft.com/office/drawing/2014/main" id="{1807E9DB-6F4D-2E48-B762-4E815C9032A8}"/>
+                <a16:creationId xmlns:a16="http://schemas.microsoft.com/office/drawing/2014/main" id="{07165EDE-5D7C-E13C-C6A7-2BC671CE97E4}"/>
               </a:ext>
             </a:extLst>
           </p:cNvPr>
@@ -176,7 +176,7 @@
           <p:cNvPr id="3" name="Subtitle 2">
             <a:extLst>
               <a:ext uri="{FF2B5EF4-FFF2-40B4-BE49-F238E27FC236}">
-                <a16:creationId xmlns:a16="http://schemas.microsoft.com/office/drawing/2014/main" id="{A6D9FC15-4DED-304A-5BF5-30B191793F86}"/>
+                <a16:creationId xmlns:a16="http://schemas.microsoft.com/office/drawing/2014/main" id="{60F28F89-A668-276C-5260-8DC28CD170D3}"/>
               </a:ext>
             </a:extLst>
           </p:cNvPr>
@@ -246,7 +246,7 @@
           <p:cNvPr id="4" name="Date Placeholder 3">
             <a:extLst>
               <a:ext uri="{FF2B5EF4-FFF2-40B4-BE49-F238E27FC236}">
-                <a16:creationId xmlns:a16="http://schemas.microsoft.com/office/drawing/2014/main" id="{6993F9F2-568C-CE13-2DCA-26852F8C3EA3}"/>
+                <a16:creationId xmlns:a16="http://schemas.microsoft.com/office/drawing/2014/main" id="{0A8E3A0F-4C08-05D4-2DD3-FF56DF14C3B0}"/>
               </a:ext>
             </a:extLst>
           </p:cNvPr>
@@ -262,7 +262,7 @@
           <a:bodyPr/>
           <a:lstStyle/>
           <a:p>
-            <a:fld id="{1403D479-A847-4CF3-8F6E-A4789BE1C28C}" type="datetimeFigureOut">
+            <a:fld id="{5B73EB7D-7B0A-49FB-956D-DA36D9BE86BC}" type="datetimeFigureOut">
               <a:rPr lang="en-US" smtClean="0"/>
               <a:t>4/6/2026</a:t>
             </a:fld>
@@ -275,7 +275,7 @@
           <p:cNvPr id="5" name="Footer Placeholder 4">
             <a:extLst>
               <a:ext uri="{FF2B5EF4-FFF2-40B4-BE49-F238E27FC236}">
-                <a16:creationId xmlns:a16="http://schemas.microsoft.com/office/drawing/2014/main" id="{254451B5-DDF7-7DB0-38CA-C3BC2B47D5DE}"/>
+                <a16:creationId xmlns:a16="http://schemas.microsoft.com/office/drawing/2014/main" id="{00115D4D-08DE-A423-CDF9-10673435AFE4}"/>
               </a:ext>
             </a:extLst>
           </p:cNvPr>
@@ -300,7 +300,7 @@
           <p:cNvPr id="6" name="Slide Number Placeholder 5">
             <a:extLst>
               <a:ext uri="{FF2B5EF4-FFF2-40B4-BE49-F238E27FC236}">
-                <a16:creationId xmlns:a16="http://schemas.microsoft.com/office/drawing/2014/main" id="{AE8835DA-F22E-C933-A0E1-0E877086F09F}"/>
+                <a16:creationId xmlns:a16="http://schemas.microsoft.com/office/drawing/2014/main" id="{DC7FA9D3-C955-3BA7-E83B-18FCFCE3490B}"/>
               </a:ext>
             </a:extLst>
           </p:cNvPr>
@@ -316,7 +316,7 @@
           <a:bodyPr/>
           <a:lstStyle/>
           <a:p>
-            <a:fld id="{6BAE5709-5EE4-4DBE-B94B-3B1DFE4C0812}" type="slidenum">
+            <a:fld id="{E97F7C3F-1559-4CBB-968A-294334B2C34B}" type="slidenum">
               <a:rPr lang="en-US" smtClean="0"/>
               <a:t>‹#›</a:t>
             </a:fld>
@@ -327,7 +327,7 @@
     </p:spTree>
     <p:extLst>
       <p:ext uri="{BB962C8B-B14F-4D97-AF65-F5344CB8AC3E}">
-        <p14:creationId xmlns:p14="http://schemas.microsoft.com/office/powerpoint/2010/main" val="3464318233"/>
+        <p14:creationId xmlns:p14="http://schemas.microsoft.com/office/powerpoint/2010/main" val="997377146"/>
       </p:ext>
     </p:extLst>
   </p:cSld>
@@ -359,7 +359,7 @@
           <p:cNvPr id="2" name="Title 1">
             <a:extLst>
               <a:ext uri="{FF2B5EF4-FFF2-40B4-BE49-F238E27FC236}">
-                <a16:creationId xmlns:a16="http://schemas.microsoft.com/office/drawing/2014/main" id="{0C7C46BE-BB37-456B-325F-1CB4F684769E}"/>
+                <a16:creationId xmlns:a16="http://schemas.microsoft.com/office/drawing/2014/main" id="{2FF81796-DA31-E286-97C8-C93169B4C320}"/>
               </a:ext>
             </a:extLst>
           </p:cNvPr>
@@ -387,7 +387,7 @@
           <p:cNvPr id="3" name="Vertical Text Placeholder 2">
             <a:extLst>
               <a:ext uri="{FF2B5EF4-FFF2-40B4-BE49-F238E27FC236}">
-                <a16:creationId xmlns:a16="http://schemas.microsoft.com/office/drawing/2014/main" id="{335D86D3-29AB-81C2-D5A7-E4F43C7C120F}"/>
+                <a16:creationId xmlns:a16="http://schemas.microsoft.com/office/drawing/2014/main" id="{45619016-DA98-93C6-130F-32E77C84C8F4}"/>
               </a:ext>
             </a:extLst>
           </p:cNvPr>
@@ -444,7 +444,7 @@
           <p:cNvPr id="4" name="Date Placeholder 3">
             <a:extLst>
               <a:ext uri="{FF2B5EF4-FFF2-40B4-BE49-F238E27FC236}">
-                <a16:creationId xmlns:a16="http://schemas.microsoft.com/office/drawing/2014/main" id="{5CA1124F-FCFE-B4A4-399D-B11F35B57FBB}"/>
+                <a16:creationId xmlns:a16="http://schemas.microsoft.com/office/drawing/2014/main" id="{0E13C730-BC39-AFAB-044E-C0F9EB364F2A}"/>
               </a:ext>
             </a:extLst>
           </p:cNvPr>
@@ -460,7 +460,7 @@
           <a:bodyPr/>
           <a:lstStyle/>
           <a:p>
-            <a:fld id="{1403D479-A847-4CF3-8F6E-A4789BE1C28C}" type="datetimeFigureOut">
+            <a:fld id="{5B73EB7D-7B0A-49FB-956D-DA36D9BE86BC}" type="datetimeFigureOut">
               <a:rPr lang="en-US" smtClean="0"/>
               <a:t>4/6/2026</a:t>
             </a:fld>
@@ -473,7 +473,7 @@
           <p:cNvPr id="5" name="Footer Placeholder 4">
             <a:extLst>
               <a:ext uri="{FF2B5EF4-FFF2-40B4-BE49-F238E27FC236}">
-                <a16:creationId xmlns:a16="http://schemas.microsoft.com/office/drawing/2014/main" id="{DFC02ED7-7E57-484B-E89F-D81226693FEF}"/>
+                <a16:creationId xmlns:a16="http://schemas.microsoft.com/office/drawing/2014/main" id="{9285CC1D-5EF3-AA0D-7B3E-51C78733F531}"/>
               </a:ext>
             </a:extLst>
           </p:cNvPr>
@@ -498,7 +498,7 @@
           <p:cNvPr id="6" name="Slide Number Placeholder 5">
             <a:extLst>
               <a:ext uri="{FF2B5EF4-FFF2-40B4-BE49-F238E27FC236}">
-                <a16:creationId xmlns:a16="http://schemas.microsoft.com/office/drawing/2014/main" id="{56E54466-5BA4-02BB-E2D6-DD1572F2F501}"/>
+                <a16:creationId xmlns:a16="http://schemas.microsoft.com/office/drawing/2014/main" id="{925369BD-5A5C-2906-48FB-6EE152784FEC}"/>
               </a:ext>
             </a:extLst>
           </p:cNvPr>
@@ -514,7 +514,7 @@
           <a:bodyPr/>
           <a:lstStyle/>
           <a:p>
-            <a:fld id="{6BAE5709-5EE4-4DBE-B94B-3B1DFE4C0812}" type="slidenum">
+            <a:fld id="{E97F7C3F-1559-4CBB-968A-294334B2C34B}" type="slidenum">
               <a:rPr lang="en-US" smtClean="0"/>
               <a:t>‹#›</a:t>
             </a:fld>
@@ -525,7 +525,7 @@
     </p:spTree>
     <p:extLst>
       <p:ext uri="{BB962C8B-B14F-4D97-AF65-F5344CB8AC3E}">
-        <p14:creationId xmlns:p14="http://schemas.microsoft.com/office/powerpoint/2010/main" val="822293293"/>
+        <p14:creationId xmlns:p14="http://schemas.microsoft.com/office/powerpoint/2010/main" val="2161666242"/>
       </p:ext>
     </p:extLst>
   </p:cSld>
@@ -557,7 +557,7 @@
           <p:cNvPr id="2" name="Vertical Title 1">
             <a:extLst>
               <a:ext uri="{FF2B5EF4-FFF2-40B4-BE49-F238E27FC236}">
-                <a16:creationId xmlns:a16="http://schemas.microsoft.com/office/drawing/2014/main" id="{FCD7685F-5945-9DE1-50CB-BF7B9442F66A}"/>
+                <a16:creationId xmlns:a16="http://schemas.microsoft.com/office/drawing/2014/main" id="{DC3930AC-3486-4AC9-662C-9C0017C35C47}"/>
               </a:ext>
             </a:extLst>
           </p:cNvPr>
@@ -590,7 +590,7 @@
           <p:cNvPr id="3" name="Vertical Text Placeholder 2">
             <a:extLst>
               <a:ext uri="{FF2B5EF4-FFF2-40B4-BE49-F238E27FC236}">
-                <a16:creationId xmlns:a16="http://schemas.microsoft.com/office/drawing/2014/main" id="{1721A90C-79F5-BF73-A5B7-D9FF3AFE8335}"/>
+                <a16:creationId xmlns:a16="http://schemas.microsoft.com/office/drawing/2014/main" id="{0BB1C3D9-1057-B5E6-21A2-AAA828C4B4E3}"/>
               </a:ext>
             </a:extLst>
           </p:cNvPr>
@@ -652,7 +652,7 @@
           <p:cNvPr id="4" name="Date Placeholder 3">
             <a:extLst>
               <a:ext uri="{FF2B5EF4-FFF2-40B4-BE49-F238E27FC236}">
-                <a16:creationId xmlns:a16="http://schemas.microsoft.com/office/drawing/2014/main" id="{5E3AE9B4-285E-E44D-B3F9-F005C010E444}"/>
+                <a16:creationId xmlns:a16="http://schemas.microsoft.com/office/drawing/2014/main" id="{B4790AF4-9570-3B4E-6726-213DB343A97D}"/>
               </a:ext>
             </a:extLst>
           </p:cNvPr>
@@ -668,7 +668,7 @@
           <a:bodyPr/>
           <a:lstStyle/>
           <a:p>
-            <a:fld id="{1403D479-A847-4CF3-8F6E-A4789BE1C28C}" type="datetimeFigureOut">
+            <a:fld id="{5B73EB7D-7B0A-49FB-956D-DA36D9BE86BC}" type="datetimeFigureOut">
               <a:rPr lang="en-US" smtClean="0"/>
               <a:t>4/6/2026</a:t>
             </a:fld>
@@ -681,7 +681,7 @@
           <p:cNvPr id="5" name="Footer Placeholder 4">
             <a:extLst>
               <a:ext uri="{FF2B5EF4-FFF2-40B4-BE49-F238E27FC236}">
-                <a16:creationId xmlns:a16="http://schemas.microsoft.com/office/drawing/2014/main" id="{FCB0610B-AA47-2607-13D3-37EEA715A52A}"/>
+                <a16:creationId xmlns:a16="http://schemas.microsoft.com/office/drawing/2014/main" id="{E57BAFBC-C74B-5B3F-2049-E3ACAE7A68FA}"/>
               </a:ext>
             </a:extLst>
           </p:cNvPr>
@@ -706,7 +706,7 @@
           <p:cNvPr id="6" name="Slide Number Placeholder 5">
             <a:extLst>
               <a:ext uri="{FF2B5EF4-FFF2-40B4-BE49-F238E27FC236}">
-                <a16:creationId xmlns:a16="http://schemas.microsoft.com/office/drawing/2014/main" id="{4A1DB8AD-C2AA-8FE2-E645-F137BE0661CA}"/>
+                <a16:creationId xmlns:a16="http://schemas.microsoft.com/office/drawing/2014/main" id="{2DF85FCA-0C73-C35C-C038-44C48043EBE4}"/>
               </a:ext>
             </a:extLst>
           </p:cNvPr>
@@ -722,7 +722,7 @@
           <a:bodyPr/>
           <a:lstStyle/>
           <a:p>
-            <a:fld id="{6BAE5709-5EE4-4DBE-B94B-3B1DFE4C0812}" type="slidenum">
+            <a:fld id="{E97F7C3F-1559-4CBB-968A-294334B2C34B}" type="slidenum">
               <a:rPr lang="en-US" smtClean="0"/>
               <a:t>‹#›</a:t>
             </a:fld>
@@ -733,7 +733,7 @@
     </p:spTree>
     <p:extLst>
       <p:ext uri="{BB962C8B-B14F-4D97-AF65-F5344CB8AC3E}">
-        <p14:creationId xmlns:p14="http://schemas.microsoft.com/office/powerpoint/2010/main" val="1137520765"/>
+        <p14:creationId xmlns:p14="http://schemas.microsoft.com/office/powerpoint/2010/main" val="1534973973"/>
       </p:ext>
     </p:extLst>
   </p:cSld>
@@ -765,7 +765,7 @@
           <p:cNvPr id="2" name="Title 1">
             <a:extLst>
               <a:ext uri="{FF2B5EF4-FFF2-40B4-BE49-F238E27FC236}">
-                <a16:creationId xmlns:a16="http://schemas.microsoft.com/office/drawing/2014/main" id="{69D79E9D-3682-400E-46AA-768FDE20F546}"/>
+                <a16:creationId xmlns:a16="http://schemas.microsoft.com/office/drawing/2014/main" id="{20ECA73E-B6CF-CDE3-3C1A-9E445B715057}"/>
               </a:ext>
             </a:extLst>
           </p:cNvPr>
@@ -793,7 +793,7 @@
           <p:cNvPr id="3" name="Content Placeholder 2">
             <a:extLst>
               <a:ext uri="{FF2B5EF4-FFF2-40B4-BE49-F238E27FC236}">
-                <a16:creationId xmlns:a16="http://schemas.microsoft.com/office/drawing/2014/main" id="{765180EB-0447-0F19-6310-46029C175462}"/>
+                <a16:creationId xmlns:a16="http://schemas.microsoft.com/office/drawing/2014/main" id="{3BB0F2EE-579A-2FF1-4991-EE0CE504FCAB}"/>
               </a:ext>
             </a:extLst>
           </p:cNvPr>
@@ -850,7 +850,7 @@
           <p:cNvPr id="4" name="Date Placeholder 3">
             <a:extLst>
               <a:ext uri="{FF2B5EF4-FFF2-40B4-BE49-F238E27FC236}">
-                <a16:creationId xmlns:a16="http://schemas.microsoft.com/office/drawing/2014/main" id="{F5A2D451-13F0-89E5-CC98-55AFFF5B370A}"/>
+                <a16:creationId xmlns:a16="http://schemas.microsoft.com/office/drawing/2014/main" id="{4BC03A41-F2E7-27E2-48C8-09B0EDA40AEB}"/>
               </a:ext>
             </a:extLst>
           </p:cNvPr>
@@ -866,7 +866,7 @@
           <a:bodyPr/>
           <a:lstStyle/>
           <a:p>
-            <a:fld id="{1403D479-A847-4CF3-8F6E-A4789BE1C28C}" type="datetimeFigureOut">
+            <a:fld id="{5B73EB7D-7B0A-49FB-956D-DA36D9BE86BC}" type="datetimeFigureOut">
               <a:rPr lang="en-US" smtClean="0"/>
               <a:t>4/6/2026</a:t>
             </a:fld>
@@ -879,7 +879,7 @@
           <p:cNvPr id="5" name="Footer Placeholder 4">
             <a:extLst>
               <a:ext uri="{FF2B5EF4-FFF2-40B4-BE49-F238E27FC236}">
-                <a16:creationId xmlns:a16="http://schemas.microsoft.com/office/drawing/2014/main" id="{C8F00702-AC6D-655C-6B08-63C44B707D15}"/>
+                <a16:creationId xmlns:a16="http://schemas.microsoft.com/office/drawing/2014/main" id="{35B860F4-1251-B554-8C68-40E9E4A7147A}"/>
               </a:ext>
             </a:extLst>
           </p:cNvPr>
@@ -904,7 +904,7 @@
           <p:cNvPr id="6" name="Slide Number Placeholder 5">
             <a:extLst>
               <a:ext uri="{FF2B5EF4-FFF2-40B4-BE49-F238E27FC236}">
-                <a16:creationId xmlns:a16="http://schemas.microsoft.com/office/drawing/2014/main" id="{2F3D3773-FFE6-0892-3B31-7A9442E7F874}"/>
+                <a16:creationId xmlns:a16="http://schemas.microsoft.com/office/drawing/2014/main" id="{CA927488-2CD3-D05E-A46C-E1BDB49623F1}"/>
               </a:ext>
             </a:extLst>
           </p:cNvPr>
@@ -920,7 +920,7 @@
           <a:bodyPr/>
           <a:lstStyle/>
           <a:p>
-            <a:fld id="{6BAE5709-5EE4-4DBE-B94B-3B1DFE4C0812}" type="slidenum">
+            <a:fld id="{E97F7C3F-1559-4CBB-968A-294334B2C34B}" type="slidenum">
               <a:rPr lang="en-US" smtClean="0"/>
               <a:t>‹#›</a:t>
             </a:fld>
@@ -931,7 +931,7 @@
     </p:spTree>
     <p:extLst>
       <p:ext uri="{BB962C8B-B14F-4D97-AF65-F5344CB8AC3E}">
-        <p14:creationId xmlns:p14="http://schemas.microsoft.com/office/powerpoint/2010/main" val="201968149"/>
+        <p14:creationId xmlns:p14="http://schemas.microsoft.com/office/powerpoint/2010/main" val="3029314847"/>
       </p:ext>
     </p:extLst>
   </p:cSld>
@@ -963,7 +963,7 @@
           <p:cNvPr id="2" name="Title 1">
             <a:extLst>
               <a:ext uri="{FF2B5EF4-FFF2-40B4-BE49-F238E27FC236}">
-                <a16:creationId xmlns:a16="http://schemas.microsoft.com/office/drawing/2014/main" id="{308875FB-A45F-5D3D-7D76-97CDBDE1D719}"/>
+                <a16:creationId xmlns:a16="http://schemas.microsoft.com/office/drawing/2014/main" id="{EE91329D-B4C1-5CCC-A3C4-66808C51FD01}"/>
               </a:ext>
             </a:extLst>
           </p:cNvPr>
@@ -1000,7 +1000,7 @@
           <p:cNvPr id="3" name="Text Placeholder 2">
             <a:extLst>
               <a:ext uri="{FF2B5EF4-FFF2-40B4-BE49-F238E27FC236}">
-                <a16:creationId xmlns:a16="http://schemas.microsoft.com/office/drawing/2014/main" id="{F8832AF4-186A-C653-6697-3B530A406C6B}"/>
+                <a16:creationId xmlns:a16="http://schemas.microsoft.com/office/drawing/2014/main" id="{8AE49EAF-01DB-32E7-358F-5A352B315129}"/>
               </a:ext>
             </a:extLst>
           </p:cNvPr>
@@ -1125,7 +1125,7 @@
           <p:cNvPr id="4" name="Date Placeholder 3">
             <a:extLst>
               <a:ext uri="{FF2B5EF4-FFF2-40B4-BE49-F238E27FC236}">
-                <a16:creationId xmlns:a16="http://schemas.microsoft.com/office/drawing/2014/main" id="{614CC4C4-8F65-DD5E-8B8F-ABC7D7E3019C}"/>
+                <a16:creationId xmlns:a16="http://schemas.microsoft.com/office/drawing/2014/main" id="{74734934-12F2-F281-6D40-21312829AAFF}"/>
               </a:ext>
             </a:extLst>
           </p:cNvPr>
@@ -1141,7 +1141,7 @@
           <a:bodyPr/>
           <a:lstStyle/>
           <a:p>
-            <a:fld id="{1403D479-A847-4CF3-8F6E-A4789BE1C28C}" type="datetimeFigureOut">
+            <a:fld id="{5B73EB7D-7B0A-49FB-956D-DA36D9BE86BC}" type="datetimeFigureOut">
               <a:rPr lang="en-US" smtClean="0"/>
               <a:t>4/6/2026</a:t>
             </a:fld>
@@ -1154,7 +1154,7 @@
           <p:cNvPr id="5" name="Footer Placeholder 4">
             <a:extLst>
               <a:ext uri="{FF2B5EF4-FFF2-40B4-BE49-F238E27FC236}">
-                <a16:creationId xmlns:a16="http://schemas.microsoft.com/office/drawing/2014/main" id="{A9FE44E5-3FD9-0316-E009-DF1201AA682A}"/>
+                <a16:creationId xmlns:a16="http://schemas.microsoft.com/office/drawing/2014/main" id="{CD198054-F9C0-A437-730F-08825FBC1A7C}"/>
               </a:ext>
             </a:extLst>
           </p:cNvPr>
@@ -1179,7 +1179,7 @@
           <p:cNvPr id="6" name="Slide Number Placeholder 5">
             <a:extLst>
               <a:ext uri="{FF2B5EF4-FFF2-40B4-BE49-F238E27FC236}">
-                <a16:creationId xmlns:a16="http://schemas.microsoft.com/office/drawing/2014/main" id="{7AC5D1C0-9F29-634E-59FB-4F883E76C99B}"/>
+                <a16:creationId xmlns:a16="http://schemas.microsoft.com/office/drawing/2014/main" id="{2ADA58BE-6890-6842-6A3B-F8458AF7A7CA}"/>
               </a:ext>
             </a:extLst>
           </p:cNvPr>
@@ -1195,7 +1195,7 @@
           <a:bodyPr/>
           <a:lstStyle/>
           <a:p>
-            <a:fld id="{6BAE5709-5EE4-4DBE-B94B-3B1DFE4C0812}" type="slidenum">
+            <a:fld id="{E97F7C3F-1559-4CBB-968A-294334B2C34B}" type="slidenum">
               <a:rPr lang="en-US" smtClean="0"/>
               <a:t>‹#›</a:t>
             </a:fld>
@@ -1206,7 +1206,7 @@
     </p:spTree>
     <p:extLst>
       <p:ext uri="{BB962C8B-B14F-4D97-AF65-F5344CB8AC3E}">
-        <p14:creationId xmlns:p14="http://schemas.microsoft.com/office/powerpoint/2010/main" val="931481198"/>
+        <p14:creationId xmlns:p14="http://schemas.microsoft.com/office/powerpoint/2010/main" val="4238659332"/>
       </p:ext>
     </p:extLst>
   </p:cSld>
@@ -1238,7 +1238,7 @@
           <p:cNvPr id="2" name="Title 1">
             <a:extLst>
               <a:ext uri="{FF2B5EF4-FFF2-40B4-BE49-F238E27FC236}">
-                <a16:creationId xmlns:a16="http://schemas.microsoft.com/office/drawing/2014/main" id="{D22D4CB8-8E80-EF81-6198-F1258615C8F3}"/>
+                <a16:creationId xmlns:a16="http://schemas.microsoft.com/office/drawing/2014/main" id="{147FD3BB-6A97-3E0C-154F-C9178372407F}"/>
               </a:ext>
             </a:extLst>
           </p:cNvPr>
@@ -1266,7 +1266,7 @@
           <p:cNvPr id="3" name="Content Placeholder 2">
             <a:extLst>
               <a:ext uri="{FF2B5EF4-FFF2-40B4-BE49-F238E27FC236}">
-                <a16:creationId xmlns:a16="http://schemas.microsoft.com/office/drawing/2014/main" id="{E83EF501-51BA-E337-BC52-B8586ED0072D}"/>
+                <a16:creationId xmlns:a16="http://schemas.microsoft.com/office/drawing/2014/main" id="{86E88B3E-FFF5-F835-7972-FEE74B994F54}"/>
               </a:ext>
             </a:extLst>
           </p:cNvPr>
@@ -1328,7 +1328,7 @@
           <p:cNvPr id="4" name="Content Placeholder 3">
             <a:extLst>
               <a:ext uri="{FF2B5EF4-FFF2-40B4-BE49-F238E27FC236}">
-                <a16:creationId xmlns:a16="http://schemas.microsoft.com/office/drawing/2014/main" id="{EA2AC2B4-0D11-35A4-57A7-447E42C1EF36}"/>
+                <a16:creationId xmlns:a16="http://schemas.microsoft.com/office/drawing/2014/main" id="{16C17DBB-FB39-2F37-8BEA-8C6D2967AE13}"/>
               </a:ext>
             </a:extLst>
           </p:cNvPr>
@@ -1390,7 +1390,7 @@
           <p:cNvPr id="5" name="Date Placeholder 4">
             <a:extLst>
               <a:ext uri="{FF2B5EF4-FFF2-40B4-BE49-F238E27FC236}">
-                <a16:creationId xmlns:a16="http://schemas.microsoft.com/office/drawing/2014/main" id="{65B37122-A647-DAD0-1034-1DA305772E6C}"/>
+                <a16:creationId xmlns:a16="http://schemas.microsoft.com/office/drawing/2014/main" id="{4ED63DFC-E240-EAC7-C836-C62105F57FD1}"/>
               </a:ext>
             </a:extLst>
           </p:cNvPr>
@@ -1406,7 +1406,7 @@
           <a:bodyPr/>
           <a:lstStyle/>
           <a:p>
-            <a:fld id="{1403D479-A847-4CF3-8F6E-A4789BE1C28C}" type="datetimeFigureOut">
+            <a:fld id="{5B73EB7D-7B0A-49FB-956D-DA36D9BE86BC}" type="datetimeFigureOut">
               <a:rPr lang="en-US" smtClean="0"/>
               <a:t>4/6/2026</a:t>
             </a:fld>
@@ -1419,7 +1419,7 @@
           <p:cNvPr id="6" name="Footer Placeholder 5">
             <a:extLst>
               <a:ext uri="{FF2B5EF4-FFF2-40B4-BE49-F238E27FC236}">
-                <a16:creationId xmlns:a16="http://schemas.microsoft.com/office/drawing/2014/main" id="{49A3998A-A703-AD8A-3B79-974227C041F3}"/>
+                <a16:creationId xmlns:a16="http://schemas.microsoft.com/office/drawing/2014/main" id="{B0BAE020-F1C9-09B3-3285-B4BCFBFA980B}"/>
               </a:ext>
             </a:extLst>
           </p:cNvPr>
@@ -1444,7 +1444,7 @@
           <p:cNvPr id="7" name="Slide Number Placeholder 6">
             <a:extLst>
               <a:ext uri="{FF2B5EF4-FFF2-40B4-BE49-F238E27FC236}">
-                <a16:creationId xmlns:a16="http://schemas.microsoft.com/office/drawing/2014/main" id="{7D6D9FDB-A537-B934-9C7C-10AE7532B047}"/>
+                <a16:creationId xmlns:a16="http://schemas.microsoft.com/office/drawing/2014/main" id="{E4D93245-5344-0F9F-39B3-4F6F4A6A7258}"/>
               </a:ext>
             </a:extLst>
           </p:cNvPr>
@@ -1460,7 +1460,7 @@
           <a:bodyPr/>
           <a:lstStyle/>
           <a:p>
-            <a:fld id="{6BAE5709-5EE4-4DBE-B94B-3B1DFE4C0812}" type="slidenum">
+            <a:fld id="{E97F7C3F-1559-4CBB-968A-294334B2C34B}" type="slidenum">
               <a:rPr lang="en-US" smtClean="0"/>
               <a:t>‹#›</a:t>
             </a:fld>
@@ -1471,7 +1471,7 @@
     </p:spTree>
     <p:extLst>
       <p:ext uri="{BB962C8B-B14F-4D97-AF65-F5344CB8AC3E}">
-        <p14:creationId xmlns:p14="http://schemas.microsoft.com/office/powerpoint/2010/main" val="496346579"/>
+        <p14:creationId xmlns:p14="http://schemas.microsoft.com/office/powerpoint/2010/main" val="2537105044"/>
       </p:ext>
     </p:extLst>
   </p:cSld>
@@ -1503,7 +1503,7 @@
           <p:cNvPr id="2" name="Title 1">
             <a:extLst>
               <a:ext uri="{FF2B5EF4-FFF2-40B4-BE49-F238E27FC236}">
-                <a16:creationId xmlns:a16="http://schemas.microsoft.com/office/drawing/2014/main" id="{C92C7359-BED8-92A8-6B78-42CD348AB3A1}"/>
+                <a16:creationId xmlns:a16="http://schemas.microsoft.com/office/drawing/2014/main" id="{AB599A54-594B-B33B-A6ED-A340DD9B9D7E}"/>
               </a:ext>
             </a:extLst>
           </p:cNvPr>
@@ -1536,7 +1536,7 @@
           <p:cNvPr id="3" name="Text Placeholder 2">
             <a:extLst>
               <a:ext uri="{FF2B5EF4-FFF2-40B4-BE49-F238E27FC236}">
-                <a16:creationId xmlns:a16="http://schemas.microsoft.com/office/drawing/2014/main" id="{B3EA9EDC-9F08-B3BE-FEFE-CD246740EAF8}"/>
+                <a16:creationId xmlns:a16="http://schemas.microsoft.com/office/drawing/2014/main" id="{AC1D8CF1-C202-91A1-C330-7BDD7ED347D4}"/>
               </a:ext>
             </a:extLst>
           </p:cNvPr>
@@ -1607,7 +1607,7 @@
           <p:cNvPr id="4" name="Content Placeholder 3">
             <a:extLst>
               <a:ext uri="{FF2B5EF4-FFF2-40B4-BE49-F238E27FC236}">
-                <a16:creationId xmlns:a16="http://schemas.microsoft.com/office/drawing/2014/main" id="{12777114-C14D-62A6-EAC8-F8D0DBE5E61A}"/>
+                <a16:creationId xmlns:a16="http://schemas.microsoft.com/office/drawing/2014/main" id="{C99BB7A1-F9CD-7C41-C65B-6C521B3FC6C5}"/>
               </a:ext>
             </a:extLst>
           </p:cNvPr>
@@ -1669,7 +1669,7 @@
           <p:cNvPr id="5" name="Text Placeholder 4">
             <a:extLst>
               <a:ext uri="{FF2B5EF4-FFF2-40B4-BE49-F238E27FC236}">
-                <a16:creationId xmlns:a16="http://schemas.microsoft.com/office/drawing/2014/main" id="{770A8120-EC70-8D1C-0274-8BDA04973C4F}"/>
+                <a16:creationId xmlns:a16="http://schemas.microsoft.com/office/drawing/2014/main" id="{BB1BBC42-1BBB-FD3C-B486-451791213799}"/>
               </a:ext>
             </a:extLst>
           </p:cNvPr>
@@ -1740,7 +1740,7 @@
           <p:cNvPr id="6" name="Content Placeholder 5">
             <a:extLst>
               <a:ext uri="{FF2B5EF4-FFF2-40B4-BE49-F238E27FC236}">
-                <a16:creationId xmlns:a16="http://schemas.microsoft.com/office/drawing/2014/main" id="{37E06DA7-7E8C-C50A-A1A3-65E6F382C290}"/>
+                <a16:creationId xmlns:a16="http://schemas.microsoft.com/office/drawing/2014/main" id="{70C1E35A-43D3-7155-540E-AE2E5141FF15}"/>
               </a:ext>
             </a:extLst>
           </p:cNvPr>
@@ -1802,7 +1802,7 @@
           <p:cNvPr id="7" name="Date Placeholder 6">
             <a:extLst>
               <a:ext uri="{FF2B5EF4-FFF2-40B4-BE49-F238E27FC236}">
-                <a16:creationId xmlns:a16="http://schemas.microsoft.com/office/drawing/2014/main" id="{A868E038-92EB-D7C2-741B-ABF37A79EB2E}"/>
+                <a16:creationId xmlns:a16="http://schemas.microsoft.com/office/drawing/2014/main" id="{20CDD3FB-D5D6-92A7-445F-012805D03410}"/>
               </a:ext>
             </a:extLst>
           </p:cNvPr>
@@ -1818,7 +1818,7 @@
           <a:bodyPr/>
           <a:lstStyle/>
           <a:p>
-            <a:fld id="{1403D479-A847-4CF3-8F6E-A4789BE1C28C}" type="datetimeFigureOut">
+            <a:fld id="{5B73EB7D-7B0A-49FB-956D-DA36D9BE86BC}" type="datetimeFigureOut">
               <a:rPr lang="en-US" smtClean="0"/>
               <a:t>4/6/2026</a:t>
             </a:fld>
@@ -1831,7 +1831,7 @@
           <p:cNvPr id="8" name="Footer Placeholder 7">
             <a:extLst>
               <a:ext uri="{FF2B5EF4-FFF2-40B4-BE49-F238E27FC236}">
-                <a16:creationId xmlns:a16="http://schemas.microsoft.com/office/drawing/2014/main" id="{84C928DD-D080-DA11-8113-B011175987B3}"/>
+                <a16:creationId xmlns:a16="http://schemas.microsoft.com/office/drawing/2014/main" id="{E218A550-269E-CF50-09FD-7570D5509990}"/>
               </a:ext>
             </a:extLst>
           </p:cNvPr>
@@ -1856,7 +1856,7 @@
           <p:cNvPr id="9" name="Slide Number Placeholder 8">
             <a:extLst>
               <a:ext uri="{FF2B5EF4-FFF2-40B4-BE49-F238E27FC236}">
-                <a16:creationId xmlns:a16="http://schemas.microsoft.com/office/drawing/2014/main" id="{F7FD2498-C4FC-DBB6-6ACB-5717EF675BEE}"/>
+                <a16:creationId xmlns:a16="http://schemas.microsoft.com/office/drawing/2014/main" id="{8C8742DA-5B22-9832-D891-05918C998070}"/>
               </a:ext>
             </a:extLst>
           </p:cNvPr>
@@ -1872,7 +1872,7 @@
           <a:bodyPr/>
           <a:lstStyle/>
           <a:p>
-            <a:fld id="{6BAE5709-5EE4-4DBE-B94B-3B1DFE4C0812}" type="slidenum">
+            <a:fld id="{E97F7C3F-1559-4CBB-968A-294334B2C34B}" type="slidenum">
               <a:rPr lang="en-US" smtClean="0"/>
               <a:t>‹#›</a:t>
             </a:fld>
@@ -1883,7 +1883,7 @@
     </p:spTree>
     <p:extLst>
       <p:ext uri="{BB962C8B-B14F-4D97-AF65-F5344CB8AC3E}">
-        <p14:creationId xmlns:p14="http://schemas.microsoft.com/office/powerpoint/2010/main" val="2711334558"/>
+        <p14:creationId xmlns:p14="http://schemas.microsoft.com/office/powerpoint/2010/main" val="2420660931"/>
       </p:ext>
     </p:extLst>
   </p:cSld>
@@ -1915,7 +1915,7 @@
           <p:cNvPr id="2" name="Title 1">
             <a:extLst>
               <a:ext uri="{FF2B5EF4-FFF2-40B4-BE49-F238E27FC236}">
-                <a16:creationId xmlns:a16="http://schemas.microsoft.com/office/drawing/2014/main" id="{5608EAD6-6C5E-0D53-B244-179CAE75EF52}"/>
+                <a16:creationId xmlns:a16="http://schemas.microsoft.com/office/drawing/2014/main" id="{1EC62CEE-C988-CAB1-B9C1-75DBF1AFE071}"/>
               </a:ext>
             </a:extLst>
           </p:cNvPr>
@@ -1943,7 +1943,7 @@
           <p:cNvPr id="3" name="Date Placeholder 2">
             <a:extLst>
               <a:ext uri="{FF2B5EF4-FFF2-40B4-BE49-F238E27FC236}">
-                <a16:creationId xmlns:a16="http://schemas.microsoft.com/office/drawing/2014/main" id="{8FB224F5-CF55-49C4-8D9C-0A846B3BA7F5}"/>
+                <a16:creationId xmlns:a16="http://schemas.microsoft.com/office/drawing/2014/main" id="{20907C4F-A9C8-4F7D-B6EE-0ABAE9B67351}"/>
               </a:ext>
             </a:extLst>
           </p:cNvPr>
@@ -1959,7 +1959,7 @@
           <a:bodyPr/>
           <a:lstStyle/>
           <a:p>
-            <a:fld id="{1403D479-A847-4CF3-8F6E-A4789BE1C28C}" type="datetimeFigureOut">
+            <a:fld id="{5B73EB7D-7B0A-49FB-956D-DA36D9BE86BC}" type="datetimeFigureOut">
               <a:rPr lang="en-US" smtClean="0"/>
               <a:t>4/6/2026</a:t>
             </a:fld>
@@ -1972,7 +1972,7 @@
           <p:cNvPr id="4" name="Footer Placeholder 3">
             <a:extLst>
               <a:ext uri="{FF2B5EF4-FFF2-40B4-BE49-F238E27FC236}">
-                <a16:creationId xmlns:a16="http://schemas.microsoft.com/office/drawing/2014/main" id="{914FA18B-96F6-5258-4E03-E70864E760A0}"/>
+                <a16:creationId xmlns:a16="http://schemas.microsoft.com/office/drawing/2014/main" id="{EBA9FC12-DE90-6E0F-4B74-91D32BE8DDED}"/>
               </a:ext>
             </a:extLst>
           </p:cNvPr>
@@ -1997,7 +1997,7 @@
           <p:cNvPr id="5" name="Slide Number Placeholder 4">
             <a:extLst>
               <a:ext uri="{FF2B5EF4-FFF2-40B4-BE49-F238E27FC236}">
-                <a16:creationId xmlns:a16="http://schemas.microsoft.com/office/drawing/2014/main" id="{8F6C2C6E-7DFB-E94D-BC3E-40C246ACE7B0}"/>
+                <a16:creationId xmlns:a16="http://schemas.microsoft.com/office/drawing/2014/main" id="{2E546593-86BA-E602-6FEB-EC0E2EA25263}"/>
               </a:ext>
             </a:extLst>
           </p:cNvPr>
@@ -2013,7 +2013,7 @@
           <a:bodyPr/>
           <a:lstStyle/>
           <a:p>
-            <a:fld id="{6BAE5709-5EE4-4DBE-B94B-3B1DFE4C0812}" type="slidenum">
+            <a:fld id="{E97F7C3F-1559-4CBB-968A-294334B2C34B}" type="slidenum">
               <a:rPr lang="en-US" smtClean="0"/>
               <a:t>‹#›</a:t>
             </a:fld>
@@ -2024,7 +2024,7 @@
     </p:spTree>
     <p:extLst>
       <p:ext uri="{BB962C8B-B14F-4D97-AF65-F5344CB8AC3E}">
-        <p14:creationId xmlns:p14="http://schemas.microsoft.com/office/powerpoint/2010/main" val="648035629"/>
+        <p14:creationId xmlns:p14="http://schemas.microsoft.com/office/powerpoint/2010/main" val="1979632611"/>
       </p:ext>
     </p:extLst>
   </p:cSld>
@@ -2056,7 +2056,7 @@
           <p:cNvPr id="2" name="Date Placeholder 1">
             <a:extLst>
               <a:ext uri="{FF2B5EF4-FFF2-40B4-BE49-F238E27FC236}">
-                <a16:creationId xmlns:a16="http://schemas.microsoft.com/office/drawing/2014/main" id="{C16556FF-929F-C81D-ABAB-7130DC25D989}"/>
+                <a16:creationId xmlns:a16="http://schemas.microsoft.com/office/drawing/2014/main" id="{860EBF8B-F458-254E-BCAE-DEDF64EF566D}"/>
               </a:ext>
             </a:extLst>
           </p:cNvPr>
@@ -2072,7 +2072,7 @@
           <a:bodyPr/>
           <a:lstStyle/>
           <a:p>
-            <a:fld id="{1403D479-A847-4CF3-8F6E-A4789BE1C28C}" type="datetimeFigureOut">
+            <a:fld id="{5B73EB7D-7B0A-49FB-956D-DA36D9BE86BC}" type="datetimeFigureOut">
               <a:rPr lang="en-US" smtClean="0"/>
               <a:t>4/6/2026</a:t>
             </a:fld>
@@ -2085,7 +2085,7 @@
           <p:cNvPr id="3" name="Footer Placeholder 2">
             <a:extLst>
               <a:ext uri="{FF2B5EF4-FFF2-40B4-BE49-F238E27FC236}">
-                <a16:creationId xmlns:a16="http://schemas.microsoft.com/office/drawing/2014/main" id="{B7D6A08A-77D2-B541-9487-65E32F670B04}"/>
+                <a16:creationId xmlns:a16="http://schemas.microsoft.com/office/drawing/2014/main" id="{8AC5E94E-69F8-CD12-6301-72C0879D7B53}"/>
               </a:ext>
             </a:extLst>
           </p:cNvPr>
@@ -2110,7 +2110,7 @@
           <p:cNvPr id="4" name="Slide Number Placeholder 3">
             <a:extLst>
               <a:ext uri="{FF2B5EF4-FFF2-40B4-BE49-F238E27FC236}">
-                <a16:creationId xmlns:a16="http://schemas.microsoft.com/office/drawing/2014/main" id="{3B8819B9-E410-25F2-C198-30FA15507040}"/>
+                <a16:creationId xmlns:a16="http://schemas.microsoft.com/office/drawing/2014/main" id="{D342F13B-F835-F254-CFD4-73521CFEBBA6}"/>
               </a:ext>
             </a:extLst>
           </p:cNvPr>
@@ -2126,7 +2126,7 @@
           <a:bodyPr/>
           <a:lstStyle/>
           <a:p>
-            <a:fld id="{6BAE5709-5EE4-4DBE-B94B-3B1DFE4C0812}" type="slidenum">
+            <a:fld id="{E97F7C3F-1559-4CBB-968A-294334B2C34B}" type="slidenum">
               <a:rPr lang="en-US" smtClean="0"/>
               <a:t>‹#›</a:t>
             </a:fld>
@@ -2137,7 +2137,7 @@
     </p:spTree>
     <p:extLst>
       <p:ext uri="{BB962C8B-B14F-4D97-AF65-F5344CB8AC3E}">
-        <p14:creationId xmlns:p14="http://schemas.microsoft.com/office/powerpoint/2010/main" val="3931165822"/>
+        <p14:creationId xmlns:p14="http://schemas.microsoft.com/office/powerpoint/2010/main" val="452856434"/>
       </p:ext>
     </p:extLst>
   </p:cSld>
@@ -2169,7 +2169,7 @@
           <p:cNvPr id="2" name="Title 1">
             <a:extLst>
               <a:ext uri="{FF2B5EF4-FFF2-40B4-BE49-F238E27FC236}">
-                <a16:creationId xmlns:a16="http://schemas.microsoft.com/office/drawing/2014/main" id="{A3147619-0365-76FA-2955-91A8C815CCF7}"/>
+                <a16:creationId xmlns:a16="http://schemas.microsoft.com/office/drawing/2014/main" id="{FE3B1A89-4810-528A-27B0-7A86C7D09B63}"/>
               </a:ext>
             </a:extLst>
           </p:cNvPr>
@@ -2206,7 +2206,7 @@
           <p:cNvPr id="3" name="Content Placeholder 2">
             <a:extLst>
               <a:ext uri="{FF2B5EF4-FFF2-40B4-BE49-F238E27FC236}">
-                <a16:creationId xmlns:a16="http://schemas.microsoft.com/office/drawing/2014/main" id="{2CBEA332-205C-F2E0-A668-5C1EFC9A6E4E}"/>
+                <a16:creationId xmlns:a16="http://schemas.microsoft.com/office/drawing/2014/main" id="{DE31025A-2165-11E7-4C06-A1B49102F173}"/>
               </a:ext>
             </a:extLst>
           </p:cNvPr>
@@ -2296,7 +2296,7 @@
           <p:cNvPr id="4" name="Text Placeholder 3">
             <a:extLst>
               <a:ext uri="{FF2B5EF4-FFF2-40B4-BE49-F238E27FC236}">
-                <a16:creationId xmlns:a16="http://schemas.microsoft.com/office/drawing/2014/main" id="{BFB7BA8D-A462-AC4C-D56F-0C87B1B4A55D}"/>
+                <a16:creationId xmlns:a16="http://schemas.microsoft.com/office/drawing/2014/main" id="{FFC4C9B6-482D-320E-DF07-F9E944998D57}"/>
               </a:ext>
             </a:extLst>
           </p:cNvPr>
@@ -2367,7 +2367,7 @@
           <p:cNvPr id="5" name="Date Placeholder 4">
             <a:extLst>
               <a:ext uri="{FF2B5EF4-FFF2-40B4-BE49-F238E27FC236}">
-                <a16:creationId xmlns:a16="http://schemas.microsoft.com/office/drawing/2014/main" id="{197CD761-CC09-A71A-487F-4E9A358F5583}"/>
+                <a16:creationId xmlns:a16="http://schemas.microsoft.com/office/drawing/2014/main" id="{BF3ABEB8-FB01-54FC-6044-7A79D69D62F9}"/>
               </a:ext>
             </a:extLst>
           </p:cNvPr>
@@ -2383,7 +2383,7 @@
           <a:bodyPr/>
           <a:lstStyle/>
           <a:p>
-            <a:fld id="{1403D479-A847-4CF3-8F6E-A4789BE1C28C}" type="datetimeFigureOut">
+            <a:fld id="{5B73EB7D-7B0A-49FB-956D-DA36D9BE86BC}" type="datetimeFigureOut">
               <a:rPr lang="en-US" smtClean="0"/>
               <a:t>4/6/2026</a:t>
             </a:fld>
@@ -2396,7 +2396,7 @@
           <p:cNvPr id="6" name="Footer Placeholder 5">
             <a:extLst>
               <a:ext uri="{FF2B5EF4-FFF2-40B4-BE49-F238E27FC236}">
-                <a16:creationId xmlns:a16="http://schemas.microsoft.com/office/drawing/2014/main" id="{99FE47DC-7FD1-4CD0-B02D-81543FAC94BC}"/>
+                <a16:creationId xmlns:a16="http://schemas.microsoft.com/office/drawing/2014/main" id="{5609FAA9-4C48-AD80-E033-DDDBE6C09033}"/>
               </a:ext>
             </a:extLst>
           </p:cNvPr>
@@ -2421,7 +2421,7 @@
           <p:cNvPr id="7" name="Slide Number Placeholder 6">
             <a:extLst>
               <a:ext uri="{FF2B5EF4-FFF2-40B4-BE49-F238E27FC236}">
-                <a16:creationId xmlns:a16="http://schemas.microsoft.com/office/drawing/2014/main" id="{82530C7C-D4AE-39CC-2C56-1A9659E6FE3A}"/>
+                <a16:creationId xmlns:a16="http://schemas.microsoft.com/office/drawing/2014/main" id="{C35540AC-8482-5215-7F2D-6E0283BD7F98}"/>
               </a:ext>
             </a:extLst>
           </p:cNvPr>
@@ -2437,7 +2437,7 @@
           <a:bodyPr/>
           <a:lstStyle/>
           <a:p>
-            <a:fld id="{6BAE5709-5EE4-4DBE-B94B-3B1DFE4C0812}" type="slidenum">
+            <a:fld id="{E97F7C3F-1559-4CBB-968A-294334B2C34B}" type="slidenum">
               <a:rPr lang="en-US" smtClean="0"/>
               <a:t>‹#›</a:t>
             </a:fld>
@@ -2448,7 +2448,7 @@
     </p:spTree>
     <p:extLst>
       <p:ext uri="{BB962C8B-B14F-4D97-AF65-F5344CB8AC3E}">
-        <p14:creationId xmlns:p14="http://schemas.microsoft.com/office/powerpoint/2010/main" val="2008238761"/>
+        <p14:creationId xmlns:p14="http://schemas.microsoft.com/office/powerpoint/2010/main" val="591662473"/>
       </p:ext>
     </p:extLst>
   </p:cSld>
@@ -2480,7 +2480,7 @@
           <p:cNvPr id="2" name="Title 1">
             <a:extLst>
               <a:ext uri="{FF2B5EF4-FFF2-40B4-BE49-F238E27FC236}">
-                <a16:creationId xmlns:a16="http://schemas.microsoft.com/office/drawing/2014/main" id="{DA258190-33A6-8BEB-1C94-757207DE92FC}"/>
+                <a16:creationId xmlns:a16="http://schemas.microsoft.com/office/drawing/2014/main" id="{DFFF123D-51F9-A8FC-D248-F88598929BEA}"/>
               </a:ext>
             </a:extLst>
           </p:cNvPr>
@@ -2517,7 +2517,7 @@
           <p:cNvPr id="3" name="Picture Placeholder 2">
             <a:extLst>
               <a:ext uri="{FF2B5EF4-FFF2-40B4-BE49-F238E27FC236}">
-                <a16:creationId xmlns:a16="http://schemas.microsoft.com/office/drawing/2014/main" id="{9D059234-81C5-E1A5-7A88-4F55FA458F97}"/>
+                <a16:creationId xmlns:a16="http://schemas.microsoft.com/office/drawing/2014/main" id="{C6DB74FA-4D6F-55C8-888D-8F05D8C66B6C}"/>
               </a:ext>
             </a:extLst>
           </p:cNvPr>
@@ -2584,7 +2584,7 @@
           <p:cNvPr id="4" name="Text Placeholder 3">
             <a:extLst>
               <a:ext uri="{FF2B5EF4-FFF2-40B4-BE49-F238E27FC236}">
-                <a16:creationId xmlns:a16="http://schemas.microsoft.com/office/drawing/2014/main" id="{E9AA9937-BF08-0103-A966-516A2F2DB6BE}"/>
+                <a16:creationId xmlns:a16="http://schemas.microsoft.com/office/drawing/2014/main" id="{5CE632E0-6802-8BD5-C0F7-275A40C794B0}"/>
               </a:ext>
             </a:extLst>
           </p:cNvPr>
@@ -2655,7 +2655,7 @@
           <p:cNvPr id="5" name="Date Placeholder 4">
             <a:extLst>
               <a:ext uri="{FF2B5EF4-FFF2-40B4-BE49-F238E27FC236}">
-                <a16:creationId xmlns:a16="http://schemas.microsoft.com/office/drawing/2014/main" id="{D74DF5EB-F421-EB66-C62B-3D4355B20060}"/>
+                <a16:creationId xmlns:a16="http://schemas.microsoft.com/office/drawing/2014/main" id="{B3A57734-0A0B-951A-5ED8-F35A6A312306}"/>
               </a:ext>
             </a:extLst>
           </p:cNvPr>
@@ -2671,7 +2671,7 @@
           <a:bodyPr/>
           <a:lstStyle/>
           <a:p>
-            <a:fld id="{1403D479-A847-4CF3-8F6E-A4789BE1C28C}" type="datetimeFigureOut">
+            <a:fld id="{5B73EB7D-7B0A-49FB-956D-DA36D9BE86BC}" type="datetimeFigureOut">
               <a:rPr lang="en-US" smtClean="0"/>
               <a:t>4/6/2026</a:t>
             </a:fld>
@@ -2684,7 +2684,7 @@
           <p:cNvPr id="6" name="Footer Placeholder 5">
             <a:extLst>
               <a:ext uri="{FF2B5EF4-FFF2-40B4-BE49-F238E27FC236}">
-                <a16:creationId xmlns:a16="http://schemas.microsoft.com/office/drawing/2014/main" id="{0A33F7AB-96BA-5520-F330-ADB6B62020DA}"/>
+                <a16:creationId xmlns:a16="http://schemas.microsoft.com/office/drawing/2014/main" id="{C11F185B-058E-51BC-08FC-C972696807CC}"/>
               </a:ext>
             </a:extLst>
           </p:cNvPr>
@@ -2709,7 +2709,7 @@
           <p:cNvPr id="7" name="Slide Number Placeholder 6">
             <a:extLst>
               <a:ext uri="{FF2B5EF4-FFF2-40B4-BE49-F238E27FC236}">
-                <a16:creationId xmlns:a16="http://schemas.microsoft.com/office/drawing/2014/main" id="{E7F51E3A-35D5-6D84-329E-6CD8B9E60F17}"/>
+                <a16:creationId xmlns:a16="http://schemas.microsoft.com/office/drawing/2014/main" id="{537F5EFC-99F2-98F7-ED1B-9F6587C63965}"/>
               </a:ext>
             </a:extLst>
           </p:cNvPr>
@@ -2725,7 +2725,7 @@
           <a:bodyPr/>
           <a:lstStyle/>
           <a:p>
-            <a:fld id="{6BAE5709-5EE4-4DBE-B94B-3B1DFE4C0812}" type="slidenum">
+            <a:fld id="{E97F7C3F-1559-4CBB-968A-294334B2C34B}" type="slidenum">
               <a:rPr lang="en-US" smtClean="0"/>
               <a:t>‹#›</a:t>
             </a:fld>
@@ -2736,7 +2736,7 @@
     </p:spTree>
     <p:extLst>
       <p:ext uri="{BB962C8B-B14F-4D97-AF65-F5344CB8AC3E}">
-        <p14:creationId xmlns:p14="http://schemas.microsoft.com/office/powerpoint/2010/main" val="3139911156"/>
+        <p14:creationId xmlns:p14="http://schemas.microsoft.com/office/powerpoint/2010/main" val="3119203166"/>
       </p:ext>
     </p:extLst>
   </p:cSld>
@@ -2773,7 +2773,7 @@
           <p:cNvPr id="2" name="Title Placeholder 1">
             <a:extLst>
               <a:ext uri="{FF2B5EF4-FFF2-40B4-BE49-F238E27FC236}">
-                <a16:creationId xmlns:a16="http://schemas.microsoft.com/office/drawing/2014/main" id="{E9146DB9-50B0-F213-F977-EAEAEE400B3A}"/>
+                <a16:creationId xmlns:a16="http://schemas.microsoft.com/office/drawing/2014/main" id="{BA0B41AD-16F1-FEBE-9436-4FBBCD28B7D4}"/>
               </a:ext>
             </a:extLst>
           </p:cNvPr>
@@ -2811,7 +2811,7 @@
           <p:cNvPr id="3" name="Text Placeholder 2">
             <a:extLst>
               <a:ext uri="{FF2B5EF4-FFF2-40B4-BE49-F238E27FC236}">
-                <a16:creationId xmlns:a16="http://schemas.microsoft.com/office/drawing/2014/main" id="{60BA4E3F-7439-2B6A-CD49-8622F7B7617D}"/>
+                <a16:creationId xmlns:a16="http://schemas.microsoft.com/office/drawing/2014/main" id="{50782CCA-CC41-77BE-2BF3-B3B3A8E523D3}"/>
               </a:ext>
             </a:extLst>
           </p:cNvPr>
@@ -2878,7 +2878,7 @@
           <p:cNvPr id="4" name="Date Placeholder 3">
             <a:extLst>
               <a:ext uri="{FF2B5EF4-FFF2-40B4-BE49-F238E27FC236}">
-                <a16:creationId xmlns:a16="http://schemas.microsoft.com/office/drawing/2014/main" id="{DACCE438-235C-47F3-23FD-F6C9F291704F}"/>
+                <a16:creationId xmlns:a16="http://schemas.microsoft.com/office/drawing/2014/main" id="{BDF55453-7154-63EB-3236-83578D188B46}"/>
               </a:ext>
             </a:extLst>
           </p:cNvPr>
@@ -2912,7 +2912,7 @@
             </a:lvl1pPr>
           </a:lstStyle>
           <a:p>
-            <a:fld id="{1403D479-A847-4CF3-8F6E-A4789BE1C28C}" type="datetimeFigureOut">
+            <a:fld id="{5B73EB7D-7B0A-49FB-956D-DA36D9BE86BC}" type="datetimeFigureOut">
               <a:rPr lang="en-US" smtClean="0"/>
               <a:t>4/6/2026</a:t>
             </a:fld>
@@ -2925,7 +2925,7 @@
           <p:cNvPr id="5" name="Footer Placeholder 4">
             <a:extLst>
               <a:ext uri="{FF2B5EF4-FFF2-40B4-BE49-F238E27FC236}">
-                <a16:creationId xmlns:a16="http://schemas.microsoft.com/office/drawing/2014/main" id="{C68D8F18-62EE-3438-B5FA-9F4BB69C8FFC}"/>
+                <a16:creationId xmlns:a16="http://schemas.microsoft.com/office/drawing/2014/main" id="{6C2B92D7-B3EC-6834-93A2-00E13B880CDA}"/>
               </a:ext>
             </a:extLst>
           </p:cNvPr>
@@ -2968,7 +2968,7 @@
           <p:cNvPr id="6" name="Slide Number Placeholder 5">
             <a:extLst>
               <a:ext uri="{FF2B5EF4-FFF2-40B4-BE49-F238E27FC236}">
-                <a16:creationId xmlns:a16="http://schemas.microsoft.com/office/drawing/2014/main" id="{D6AF577D-9F7F-66ED-A262-31EB2A015C4B}"/>
+                <a16:creationId xmlns:a16="http://schemas.microsoft.com/office/drawing/2014/main" id="{2AD40F38-C389-A194-FB37-D3C0A3B2714A}"/>
               </a:ext>
             </a:extLst>
           </p:cNvPr>
@@ -3002,7 +3002,7 @@
             </a:lvl1pPr>
           </a:lstStyle>
           <a:p>
-            <a:fld id="{6BAE5709-5EE4-4DBE-B94B-3B1DFE4C0812}" type="slidenum">
+            <a:fld id="{E97F7C3F-1559-4CBB-968A-294334B2C34B}" type="slidenum">
               <a:rPr lang="en-US" smtClean="0"/>
               <a:t>‹#›</a:t>
             </a:fld>
@@ -3013,7 +3013,7 @@
     </p:spTree>
     <p:extLst>
       <p:ext uri="{BB962C8B-B14F-4D97-AF65-F5344CB8AC3E}">
-        <p14:creationId xmlns:p14="http://schemas.microsoft.com/office/powerpoint/2010/main" val="1350075904"/>
+        <p14:creationId xmlns:p14="http://schemas.microsoft.com/office/powerpoint/2010/main" val="1304328081"/>
       </p:ext>
     </p:extLst>
   </p:cSld>
@@ -3336,7 +3336,7 @@
           <p:cNvPr id="2" name="Title 1">
             <a:extLst>
               <a:ext uri="{FF2B5EF4-FFF2-40B4-BE49-F238E27FC236}">
-                <a16:creationId xmlns:a16="http://schemas.microsoft.com/office/drawing/2014/main" id="{E7AEF408-FD89-9687-66D1-DAB2A5DA6621}"/>
+                <a16:creationId xmlns:a16="http://schemas.microsoft.com/office/drawing/2014/main" id="{6D0508D7-6434-994C-9D6E-CD375C27E438}"/>
               </a:ext>
             </a:extLst>
           </p:cNvPr>
@@ -3368,7 +3368,7 @@
           <p:cNvPr id="3" name="TextBox 2">
             <a:extLst>
               <a:ext uri="{FF2B5EF4-FFF2-40B4-BE49-F238E27FC236}">
-                <a16:creationId xmlns:a16="http://schemas.microsoft.com/office/drawing/2014/main" id="{7A823A76-8611-B383-C997-3320A78C0ABB}"/>
+                <a16:creationId xmlns:a16="http://schemas.microsoft.com/office/drawing/2014/main" id="{B9035441-7FD7-AB93-649A-F309FE706EF7}"/>
               </a:ext>
             </a:extLst>
           </p:cNvPr>
@@ -3459,7 +3459,7 @@
     </p:spTree>
     <p:extLst>
       <p:ext uri="{BB962C8B-B14F-4D97-AF65-F5344CB8AC3E}">
-        <p14:creationId xmlns:p14="http://schemas.microsoft.com/office/powerpoint/2010/main" val="1093404983"/>
+        <p14:creationId xmlns:p14="http://schemas.microsoft.com/office/powerpoint/2010/main" val="2356384875"/>
       </p:ext>
     </p:extLst>
   </p:cSld>
@@ -3491,7 +3491,7 @@
           <p:cNvPr id="2" name="Title 1">
             <a:extLst>
               <a:ext uri="{FF2B5EF4-FFF2-40B4-BE49-F238E27FC236}">
-                <a16:creationId xmlns:a16="http://schemas.microsoft.com/office/drawing/2014/main" id="{7D3896CB-3504-B9A4-3EE3-072436B68B73}"/>
+                <a16:creationId xmlns:a16="http://schemas.microsoft.com/office/drawing/2014/main" id="{E5BB1566-0724-81F4-07DE-416CC7336CD4}"/>
               </a:ext>
             </a:extLst>
           </p:cNvPr>
@@ -3523,7 +3523,7 @@
           <p:cNvPr id="3" name="TextBox 2">
             <a:extLst>
               <a:ext uri="{FF2B5EF4-FFF2-40B4-BE49-F238E27FC236}">
-                <a16:creationId xmlns:a16="http://schemas.microsoft.com/office/drawing/2014/main" id="{DF393AC6-3A3D-37D3-12B7-073C49C05C8C}"/>
+                <a16:creationId xmlns:a16="http://schemas.microsoft.com/office/drawing/2014/main" id="{6AD3832E-9A38-01C3-1518-37380CD426CB}"/>
               </a:ext>
             </a:extLst>
           </p:cNvPr>
@@ -3558,47 +3558,31 @@
               <a:rPr lang="en-US" sz="2200">
                 <a:latin typeface="Aptos" panose="020B0004020202020204" pitchFamily="34" charset="0"/>
               </a:rPr>
-              <a:t>1. open the GitHub Issue for BUG-20260406-001</a:t>
-            </a:r>
-          </a:p>
-          <a:p>
-            <a:r>
-              <a:rPr lang="en-US" sz="2200">
-                <a:latin typeface="Aptos" panose="020B0004020202020204" pitchFamily="34" charset="0"/>
-              </a:rPr>
-              <a:t>2. fix and retest invoice creation</a:t>
-            </a:r>
-          </a:p>
-          <a:p>
-            <a:r>
-              <a:rPr lang="en-US" sz="2200">
-                <a:latin typeface="Aptos" panose="020B0004020202020204" pitchFamily="34" charset="0"/>
-              </a:rPr>
-              <a:t>3. execute stock, reports, products, and public-catalog UI flows</a:t>
-            </a:r>
-          </a:p>
-          <a:p>
-            <a:r>
-              <a:rPr lang="en-US" sz="2200">
-                <a:latin typeface="Aptos" panose="020B0004020202020204" pitchFamily="34" charset="0"/>
-              </a:rPr>
-              <a:t>4. commit the generated final PDF and PPTX artifacts</a:t>
-            </a:r>
-          </a:p>
-          <a:p>
-            <a:r>
-              <a:rPr lang="en-US" sz="2200">
-                <a:latin typeface="Aptos" panose="020B0004020202020204" pitchFamily="34" charset="0"/>
-              </a:rPr>
-              <a:t>5. commit the generated automation video artifact</a:t>
-            </a:r>
-          </a:p>
-          <a:p>
-            <a:r>
-              <a:rPr lang="en-US" sz="2200">
-                <a:latin typeface="Aptos" panose="020B0004020202020204" pitchFamily="34" charset="0"/>
-              </a:rPr>
-              <a:t>6. add optional cross-browser evidence if Edge is available</a:t>
+              <a:t>1. fix and retest invoice creation through GitHub Issue #1</a:t>
+            </a:r>
+          </a:p>
+          <a:p>
+            <a:r>
+              <a:rPr lang="en-US" sz="2200">
+                <a:latin typeface="Aptos" panose="020B0004020202020204" pitchFamily="34" charset="0"/>
+              </a:rPr>
+              <a:t>2. execute stock, reports, products, and public-catalog UI flows</a:t>
+            </a:r>
+          </a:p>
+          <a:p>
+            <a:r>
+              <a:rPr lang="en-US" sz="2200">
+                <a:latin typeface="Aptos" panose="020B0004020202020204" pitchFamily="34" charset="0"/>
+              </a:rPr>
+              <a:t>3. add optional cross-browser evidence if Edge is available</a:t>
+            </a:r>
+          </a:p>
+          <a:p>
+            <a:r>
+              <a:rPr lang="en-US" sz="2200">
+                <a:latin typeface="Aptos" panose="020B0004020202020204" pitchFamily="34" charset="0"/>
+              </a:rPr>
+              <a:t>4. refresh the report, slides, and metrics only if new execution evidence is added</a:t>
             </a:r>
           </a:p>
           <a:p>
@@ -3686,7 +3670,7 @@
     </p:spTree>
     <p:extLst>
       <p:ext uri="{BB962C8B-B14F-4D97-AF65-F5344CB8AC3E}">
-        <p14:creationId xmlns:p14="http://schemas.microsoft.com/office/powerpoint/2010/main" val="2507029779"/>
+        <p14:creationId xmlns:p14="http://schemas.microsoft.com/office/powerpoint/2010/main" val="5107406"/>
       </p:ext>
     </p:extLst>
   </p:cSld>
@@ -3718,7 +3702,7 @@
           <p:cNvPr id="2" name="Title 1">
             <a:extLst>
               <a:ext uri="{FF2B5EF4-FFF2-40B4-BE49-F238E27FC236}">
-                <a16:creationId xmlns:a16="http://schemas.microsoft.com/office/drawing/2014/main" id="{71B51FF3-B04D-5672-F894-5C5E76E004A6}"/>
+                <a16:creationId xmlns:a16="http://schemas.microsoft.com/office/drawing/2014/main" id="{CC82FE49-E38A-F33B-ACDC-AB1E0F40AF9A}"/>
               </a:ext>
             </a:extLst>
           </p:cNvPr>
@@ -3750,7 +3734,7 @@
           <p:cNvPr id="3" name="TextBox 2">
             <a:extLst>
               <a:ext uri="{FF2B5EF4-FFF2-40B4-BE49-F238E27FC236}">
-                <a16:creationId xmlns:a16="http://schemas.microsoft.com/office/drawing/2014/main" id="{990AB6CA-1738-A76A-170F-88B11A908467}"/>
+                <a16:creationId xmlns:a16="http://schemas.microsoft.com/office/drawing/2014/main" id="{3785592A-75EA-2DE8-1EAF-90DA1109A766}"/>
               </a:ext>
             </a:extLst>
           </p:cNvPr>
@@ -3825,7 +3809,7 @@
     </p:spTree>
     <p:extLst>
       <p:ext uri="{BB962C8B-B14F-4D97-AF65-F5344CB8AC3E}">
-        <p14:creationId xmlns:p14="http://schemas.microsoft.com/office/powerpoint/2010/main" val="833437793"/>
+        <p14:creationId xmlns:p14="http://schemas.microsoft.com/office/powerpoint/2010/main" val="1639513748"/>
       </p:ext>
     </p:extLst>
   </p:cSld>
@@ -3857,7 +3841,7 @@
           <p:cNvPr id="2" name="Title 1">
             <a:extLst>
               <a:ext uri="{FF2B5EF4-FFF2-40B4-BE49-F238E27FC236}">
-                <a16:creationId xmlns:a16="http://schemas.microsoft.com/office/drawing/2014/main" id="{65B85A2B-E87B-096E-5B0E-F177187A648E}"/>
+                <a16:creationId xmlns:a16="http://schemas.microsoft.com/office/drawing/2014/main" id="{AC126338-FB36-5652-8169-60D829926D58}"/>
               </a:ext>
             </a:extLst>
           </p:cNvPr>
@@ -3889,7 +3873,7 @@
           <p:cNvPr id="3" name="TextBox 2">
             <a:extLst>
               <a:ext uri="{FF2B5EF4-FFF2-40B4-BE49-F238E27FC236}">
-                <a16:creationId xmlns:a16="http://schemas.microsoft.com/office/drawing/2014/main" id="{25713BAD-D8CA-7365-46B2-892CA481763A}"/>
+                <a16:creationId xmlns:a16="http://schemas.microsoft.com/office/drawing/2014/main" id="{C8BCE852-0112-B422-A2B9-FA2B278DCAF4}"/>
               </a:ext>
             </a:extLst>
           </p:cNvPr>
@@ -4004,7 +3988,7 @@
     </p:spTree>
     <p:extLst>
       <p:ext uri="{BB962C8B-B14F-4D97-AF65-F5344CB8AC3E}">
-        <p14:creationId xmlns:p14="http://schemas.microsoft.com/office/powerpoint/2010/main" val="2193095689"/>
+        <p14:creationId xmlns:p14="http://schemas.microsoft.com/office/powerpoint/2010/main" val="1826235433"/>
       </p:ext>
     </p:extLst>
   </p:cSld>
@@ -4036,7 +4020,7 @@
           <p:cNvPr id="2" name="Title 1">
             <a:extLst>
               <a:ext uri="{FF2B5EF4-FFF2-40B4-BE49-F238E27FC236}">
-                <a16:creationId xmlns:a16="http://schemas.microsoft.com/office/drawing/2014/main" id="{D33B8192-C5E9-74B2-2F53-AC4BE53CD8EB}"/>
+                <a16:creationId xmlns:a16="http://schemas.microsoft.com/office/drawing/2014/main" id="{1E5E429B-A4D4-32B1-8829-07A9A2119E5E}"/>
               </a:ext>
             </a:extLst>
           </p:cNvPr>
@@ -4068,7 +4052,7 @@
           <p:cNvPr id="3" name="TextBox 2">
             <a:extLst>
               <a:ext uri="{FF2B5EF4-FFF2-40B4-BE49-F238E27FC236}">
-                <a16:creationId xmlns:a16="http://schemas.microsoft.com/office/drawing/2014/main" id="{4C4458D1-0012-613F-DC17-EFF3D5D6AA12}"/>
+                <a16:creationId xmlns:a16="http://schemas.microsoft.com/office/drawing/2014/main" id="{825F0083-E79E-D4CD-3D93-B98D24E98905}"/>
               </a:ext>
             </a:extLst>
           </p:cNvPr>
@@ -4167,7 +4151,7 @@
     </p:spTree>
     <p:extLst>
       <p:ext uri="{BB962C8B-B14F-4D97-AF65-F5344CB8AC3E}">
-        <p14:creationId xmlns:p14="http://schemas.microsoft.com/office/powerpoint/2010/main" val="3555988087"/>
+        <p14:creationId xmlns:p14="http://schemas.microsoft.com/office/powerpoint/2010/main" val="90837247"/>
       </p:ext>
     </p:extLst>
   </p:cSld>
@@ -4199,7 +4183,7 @@
           <p:cNvPr id="2" name="Title 1">
             <a:extLst>
               <a:ext uri="{FF2B5EF4-FFF2-40B4-BE49-F238E27FC236}">
-                <a16:creationId xmlns:a16="http://schemas.microsoft.com/office/drawing/2014/main" id="{C43A5B74-38A0-7540-1C28-6C6CFE41125A}"/>
+                <a16:creationId xmlns:a16="http://schemas.microsoft.com/office/drawing/2014/main" id="{0FD2E701-7A5C-250F-5657-BE6C15AA70A3}"/>
               </a:ext>
             </a:extLst>
           </p:cNvPr>
@@ -4231,7 +4215,7 @@
           <p:cNvPr id="3" name="TextBox 2">
             <a:extLst>
               <a:ext uri="{FF2B5EF4-FFF2-40B4-BE49-F238E27FC236}">
-                <a16:creationId xmlns:a16="http://schemas.microsoft.com/office/drawing/2014/main" id="{2240130A-64E4-309F-A581-0B3F1427C783}"/>
+                <a16:creationId xmlns:a16="http://schemas.microsoft.com/office/drawing/2014/main" id="{E4240C48-B7AA-F07F-7FBC-683FF436B0D7}"/>
               </a:ext>
             </a:extLst>
           </p:cNvPr>
@@ -4338,7 +4322,7 @@
     </p:spTree>
     <p:extLst>
       <p:ext uri="{BB962C8B-B14F-4D97-AF65-F5344CB8AC3E}">
-        <p14:creationId xmlns:p14="http://schemas.microsoft.com/office/powerpoint/2010/main" val="2340284969"/>
+        <p14:creationId xmlns:p14="http://schemas.microsoft.com/office/powerpoint/2010/main" val="1102452476"/>
       </p:ext>
     </p:extLst>
   </p:cSld>
@@ -4370,7 +4354,7 @@
           <p:cNvPr id="2" name="Title 1">
             <a:extLst>
               <a:ext uri="{FF2B5EF4-FFF2-40B4-BE49-F238E27FC236}">
-                <a16:creationId xmlns:a16="http://schemas.microsoft.com/office/drawing/2014/main" id="{31299160-78C7-0DBD-8A77-901F25F5CA56}"/>
+                <a16:creationId xmlns:a16="http://schemas.microsoft.com/office/drawing/2014/main" id="{9DD660EB-1063-0BF5-9B4E-6F6006B01CF2}"/>
               </a:ext>
             </a:extLst>
           </p:cNvPr>
@@ -4402,7 +4386,7 @@
           <p:cNvPr id="3" name="TextBox 2">
             <a:extLst>
               <a:ext uri="{FF2B5EF4-FFF2-40B4-BE49-F238E27FC236}">
-                <a16:creationId xmlns:a16="http://schemas.microsoft.com/office/drawing/2014/main" id="{AF7CC265-1AE8-9C0C-E965-B3D55092BB18}"/>
+                <a16:creationId xmlns:a16="http://schemas.microsoft.com/office/drawing/2014/main" id="{638FD2B1-CB9C-A6F6-9BAD-035F929A3B31}"/>
               </a:ext>
             </a:extLst>
           </p:cNvPr>
@@ -4517,7 +4501,7 @@
     </p:spTree>
     <p:extLst>
       <p:ext uri="{BB962C8B-B14F-4D97-AF65-F5344CB8AC3E}">
-        <p14:creationId xmlns:p14="http://schemas.microsoft.com/office/powerpoint/2010/main" val="1720811817"/>
+        <p14:creationId xmlns:p14="http://schemas.microsoft.com/office/powerpoint/2010/main" val="2377625165"/>
       </p:ext>
     </p:extLst>
   </p:cSld>
@@ -4549,7 +4533,7 @@
           <p:cNvPr id="2" name="Title 1">
             <a:extLst>
               <a:ext uri="{FF2B5EF4-FFF2-40B4-BE49-F238E27FC236}">
-                <a16:creationId xmlns:a16="http://schemas.microsoft.com/office/drawing/2014/main" id="{32892C36-F73E-D039-ACDC-422B84FBFAC7}"/>
+                <a16:creationId xmlns:a16="http://schemas.microsoft.com/office/drawing/2014/main" id="{3A24C8C5-0B5E-AE1C-99A2-E99A89DB9DA4}"/>
               </a:ext>
             </a:extLst>
           </p:cNvPr>
@@ -4581,7 +4565,7 @@
           <p:cNvPr id="3" name="TextBox 2">
             <a:extLst>
               <a:ext uri="{FF2B5EF4-FFF2-40B4-BE49-F238E27FC236}">
-                <a16:creationId xmlns:a16="http://schemas.microsoft.com/office/drawing/2014/main" id="{DD201614-D677-5487-4B8A-8F3AC592531E}"/>
+                <a16:creationId xmlns:a16="http://schemas.microsoft.com/office/drawing/2014/main" id="{F1DB1003-83CC-8A69-B9FD-09A707A6CB41}"/>
               </a:ext>
             </a:extLst>
           </p:cNvPr>
@@ -4698,7 +4682,7 @@
           <p:cNvPr id="5" name="Picture 4">
             <a:extLst>
               <a:ext uri="{FF2B5EF4-FFF2-40B4-BE49-F238E27FC236}">
-                <a16:creationId xmlns:a16="http://schemas.microsoft.com/office/drawing/2014/main" id="{4F28CEBE-FA00-ECA8-BE6B-EFCCB8556CB5}"/>
+                <a16:creationId xmlns:a16="http://schemas.microsoft.com/office/drawing/2014/main" id="{7B904C25-E4D9-C62C-F23C-A2CF3945510F}"/>
               </a:ext>
             </a:extLst>
           </p:cNvPr>
@@ -4732,7 +4716,7 @@
     </p:spTree>
     <p:extLst>
       <p:ext uri="{BB962C8B-B14F-4D97-AF65-F5344CB8AC3E}">
-        <p14:creationId xmlns:p14="http://schemas.microsoft.com/office/powerpoint/2010/main" val="4040960445"/>
+        <p14:creationId xmlns:p14="http://schemas.microsoft.com/office/powerpoint/2010/main" val="152540746"/>
       </p:ext>
     </p:extLst>
   </p:cSld>
@@ -4764,7 +4748,7 @@
           <p:cNvPr id="2" name="Title 1">
             <a:extLst>
               <a:ext uri="{FF2B5EF4-FFF2-40B4-BE49-F238E27FC236}">
-                <a16:creationId xmlns:a16="http://schemas.microsoft.com/office/drawing/2014/main" id="{57C803E9-8E76-3DEB-6D2E-970E042A2F13}"/>
+                <a16:creationId xmlns:a16="http://schemas.microsoft.com/office/drawing/2014/main" id="{CC84FC0F-10C8-46F3-8460-3A8616E25D0D}"/>
               </a:ext>
             </a:extLst>
           </p:cNvPr>
@@ -4796,7 +4780,7 @@
           <p:cNvPr id="3" name="TextBox 2">
             <a:extLst>
               <a:ext uri="{FF2B5EF4-FFF2-40B4-BE49-F238E27FC236}">
-                <a16:creationId xmlns:a16="http://schemas.microsoft.com/office/drawing/2014/main" id="{6359D2AB-2CA8-A9EC-64A7-F477ACBB7CB7}"/>
+                <a16:creationId xmlns:a16="http://schemas.microsoft.com/office/drawing/2014/main" id="{3777F997-021C-FF75-9AD7-D96EAB885711}"/>
               </a:ext>
             </a:extLst>
           </p:cNvPr>
@@ -4908,10 +4892,46 @@
           </a:p>
         </p:txBody>
       </p:sp>
+      <p:pic>
+        <p:nvPicPr>
+          <p:cNvPr id="5" name="Picture 4">
+            <a:extLst>
+              <a:ext uri="{FF2B5EF4-FFF2-40B4-BE49-F238E27FC236}">
+                <a16:creationId xmlns:a16="http://schemas.microsoft.com/office/drawing/2014/main" id="{4901DD80-59CF-E742-E7FF-7AA7D6D71E55}"/>
+              </a:ext>
+            </a:extLst>
+          </p:cNvPr>
+          <p:cNvPicPr>
+            <a:picLocks/>
+          </p:cNvPicPr>
+          <p:nvPr/>
+        </p:nvPicPr>
+        <p:blipFill>
+          <a:blip r:embed="rId2">
+            <a:extLst>
+              <a:ext uri="{28A0092B-C50C-407E-A947-70E740481C1C}">
+                <a14:useLocalDpi xmlns:a14="http://schemas.microsoft.com/office/drawing/2010/main" val="0"/>
+              </a:ext>
+            </a:extLst>
+          </a:blip>
+          <a:stretch>
+            <a:fillRect/>
+          </a:stretch>
+        </p:blipFill>
+        <p:spPr>
+          <a:xfrm>
+            <a:off x="7874000" y="1524000"/>
+            <a:ext cx="7874000" cy="4445000"/>
+          </a:xfrm>
+          <a:prstGeom prst="rect">
+            <a:avLst/>
+          </a:prstGeom>
+        </p:spPr>
+      </p:pic>
     </p:spTree>
     <p:extLst>
       <p:ext uri="{BB962C8B-B14F-4D97-AF65-F5344CB8AC3E}">
-        <p14:creationId xmlns:p14="http://schemas.microsoft.com/office/powerpoint/2010/main" val="494659665"/>
+        <p14:creationId xmlns:p14="http://schemas.microsoft.com/office/powerpoint/2010/main" val="537355378"/>
       </p:ext>
     </p:extLst>
   </p:cSld>
@@ -4943,7 +4963,7 @@
           <p:cNvPr id="2" name="Title 1">
             <a:extLst>
               <a:ext uri="{FF2B5EF4-FFF2-40B4-BE49-F238E27FC236}">
-                <a16:creationId xmlns:a16="http://schemas.microsoft.com/office/drawing/2014/main" id="{DA9ED0A0-096B-54C5-457F-8A1F284AC855}"/>
+                <a16:creationId xmlns:a16="http://schemas.microsoft.com/office/drawing/2014/main" id="{253D446E-79E7-922A-38D6-FAC8BD1F6C43}"/>
               </a:ext>
             </a:extLst>
           </p:cNvPr>
@@ -4975,7 +4995,7 @@
           <p:cNvPr id="3" name="TextBox 2">
             <a:extLst>
               <a:ext uri="{FF2B5EF4-FFF2-40B4-BE49-F238E27FC236}">
-                <a16:creationId xmlns:a16="http://schemas.microsoft.com/office/drawing/2014/main" id="{B155C07F-EA6C-E2DF-FB3D-449EDD4C43F6}"/>
+                <a16:creationId xmlns:a16="http://schemas.microsoft.com/office/drawing/2014/main" id="{3EAAEFE8-2617-6E9D-C247-65A2A8731094}"/>
               </a:ext>
             </a:extLst>
           </p:cNvPr>
@@ -4985,7 +5005,7 @@
         <p:spPr>
           <a:xfrm>
             <a:off x="698500" y="1587500"/>
-            <a:ext cx="6604000" cy="3816429"/>
+            <a:ext cx="6604000" cy="4154984"/>
           </a:xfrm>
           <a:prstGeom prst="rect">
             <a:avLst/>
@@ -5026,6 +5046,14 @@
               <a:rPr lang="en-US" sz="2200">
                 <a:latin typeface="Aptos" panose="020B0004020202020204" pitchFamily="34" charset="0"/>
               </a:rPr>
+              <a:t>tracked in GitHub Issue #1</a:t>
+            </a:r>
+          </a:p>
+          <a:p>
+            <a:r>
+              <a:rPr lang="en-US" sz="2200">
+                <a:latin typeface="Aptos" panose="020B0004020202020204" pitchFamily="34" charset="0"/>
+              </a:rPr>
               <a:t>Closed Observations</a:t>
             </a:r>
           </a:p>
@@ -5087,10 +5115,46 @@
           </a:p>
         </p:txBody>
       </p:sp>
+      <p:pic>
+        <p:nvPicPr>
+          <p:cNvPr id="5" name="Picture 4">
+            <a:extLst>
+              <a:ext uri="{FF2B5EF4-FFF2-40B4-BE49-F238E27FC236}">
+                <a16:creationId xmlns:a16="http://schemas.microsoft.com/office/drawing/2014/main" id="{7551688F-6906-4BE2-05E1-096A046051F4}"/>
+              </a:ext>
+            </a:extLst>
+          </p:cNvPr>
+          <p:cNvPicPr>
+            <a:picLocks/>
+          </p:cNvPicPr>
+          <p:nvPr/>
+        </p:nvPicPr>
+        <p:blipFill>
+          <a:blip r:embed="rId2">
+            <a:extLst>
+              <a:ext uri="{28A0092B-C50C-407E-A947-70E740481C1C}">
+                <a14:useLocalDpi xmlns:a14="http://schemas.microsoft.com/office/drawing/2010/main" val="0"/>
+              </a:ext>
+            </a:extLst>
+          </a:blip>
+          <a:stretch>
+            <a:fillRect/>
+          </a:stretch>
+        </p:blipFill>
+        <p:spPr>
+          <a:xfrm>
+            <a:off x="7874000" y="1524000"/>
+            <a:ext cx="7874000" cy="4445000"/>
+          </a:xfrm>
+          <a:prstGeom prst="rect">
+            <a:avLst/>
+          </a:prstGeom>
+        </p:spPr>
+      </p:pic>
     </p:spTree>
     <p:extLst>
       <p:ext uri="{BB962C8B-B14F-4D97-AF65-F5344CB8AC3E}">
-        <p14:creationId xmlns:p14="http://schemas.microsoft.com/office/powerpoint/2010/main" val="2371999054"/>
+        <p14:creationId xmlns:p14="http://schemas.microsoft.com/office/powerpoint/2010/main" val="3482193108"/>
       </p:ext>
     </p:extLst>
   </p:cSld>
@@ -5122,7 +5186,7 @@
           <p:cNvPr id="2" name="Title 1">
             <a:extLst>
               <a:ext uri="{FF2B5EF4-FFF2-40B4-BE49-F238E27FC236}">
-                <a16:creationId xmlns:a16="http://schemas.microsoft.com/office/drawing/2014/main" id="{8169ABB0-C4EC-556D-505E-950CA533366D}"/>
+                <a16:creationId xmlns:a16="http://schemas.microsoft.com/office/drawing/2014/main" id="{349BC4BE-6EB4-A828-0EC8-784ADED82E04}"/>
               </a:ext>
             </a:extLst>
           </p:cNvPr>
@@ -5154,7 +5218,7 @@
           <p:cNvPr id="3" name="TextBox 2">
             <a:extLst>
               <a:ext uri="{FF2B5EF4-FFF2-40B4-BE49-F238E27FC236}">
-                <a16:creationId xmlns:a16="http://schemas.microsoft.com/office/drawing/2014/main" id="{E2A124F3-71D0-808E-07EF-E76B4E711408}"/>
+                <a16:creationId xmlns:a16="http://schemas.microsoft.com/office/drawing/2014/main" id="{B32AD166-5238-ED40-A0FE-8725D591A66A}"/>
               </a:ext>
             </a:extLst>
           </p:cNvPr>
@@ -5245,7 +5309,7 @@
     </p:spTree>
     <p:extLst>
       <p:ext uri="{BB962C8B-B14F-4D97-AF65-F5344CB8AC3E}">
-        <p14:creationId xmlns:p14="http://schemas.microsoft.com/office/powerpoint/2010/main" val="2227144958"/>
+        <p14:creationId xmlns:p14="http://schemas.microsoft.com/office/powerpoint/2010/main" val="1807001261"/>
       </p:ext>
     </p:extLst>
   </p:cSld>

</xml_diff>